<commit_message>
Interface bilingue FR/EN + suppression des emojis (icones Font Awesome)
- Ajout d'un systeme d'i18n (modules/i18n.py) et d'une bascule de langue
  FR/EN ; bandeau, navigation, sidebar, KPI, panneaux, tableaux, onglet
  Recommandations et Auteur entierement traduits, y compris les axes et
  series des graphiques.
- Suppression de toutes les emojis de l'application ; remplacement par des
  icones Font Awesome integrees (faicons) illustrant chaque onglet et chaque
  indicateur (KPI, panneaux).
- Libelles et choix des filtres mis a jour dynamiquement au changement de
  langue (valeurs canoniques conservees pour la logique de filtrage).
- requirements.txt : ajout de faicons ; README et PPTX mis a jour.

Co-Authored-By: Claude Opus 4.8 <noreply@anthropic.com>
Claude-Session: https://claude.ai/code/session_01KX6eYWbwJYU2YKubHfKoZx
</commit_message>
<xml_diff>
--- a/dashboard_econ_num/rapport/Presentation_Economie_Numerique_Togo.pptx
+++ b/dashboard_econ_num/rapport/Presentation_Economie_Numerique_Togo.pptx
@@ -4261,7 +4261,7 @@
                   <a:srgbClr val="6B7B76"/>
                 </a:solidFill>
               </a:rPr>
-              <a:t>📷 Capture d'ecran du tableau de bord
+              <a:t>[ ] Capture d'ecran du tableau de bord
 (page d'accueil — a inserer)</a:t>
             </a:r>
           </a:p>
@@ -7500,7 +7500,7 @@
                   <a:srgbClr val="6B7B76"/>
                 </a:solidFill>
               </a:rPr>
-              <a:t>📷 Capture : carte des priorites
+              <a:t>[ ] Capture : carte des priorites
 (onglet « Carte » du dashboard)</a:t>
             </a:r>
           </a:p>

</xml_diff>